<commit_message>
fix: relabel unverified claims as design targets across all decks
Audit traced every metric to source code. Fixes applied to web deck,
both PDF generators, and both PPTX generators:

Performance table: split into Simulated/Verified (left) vs Design
Targets (right) — 241 nodes, RL routing, QKD, 200x radiation are
backed by run_simulation.py seed=42; 2-200 Mbps, >95% availability,
/usr/bin/zsh.01/MB are now clearly labelled as model-based targets

RL Routing: replaced unverified 97% delivery / -20% time with
verified training convergence stats (~140 ep, epsilon->0.018)

Other fixes:
- 27 -> 25 Python modules (actual count)
- <5% DTN overhead -> (target)
- 100% link utilization -> (target)
- 5/6 items delivered -> (scenario)
- ~13 min total transit -> (theoretical)
- 10-100x 'Faster' -> 'Target/Capability' throughout
- Speaker notes updated to match honest framing
- Regenerated all 4 deck files (PDF+PPTX, full+compact)
- Synced to docs/downloads/ (md5 verified)
</commit_message>
<xml_diff>
--- a/docs/downloads/AETHERIX_Presentation.pptx
+++ b/docs/downloads/AETHERIX_Presentation.pptx
@@ -2721,7 +2721,7 @@
           <a:lstStyle/>
           <a:p>
             <a:r>
-              <a:t>Hit these numbers with confidence. 10-100x faster. &gt;95% availability vs 60-75%. Quantum-secure. 241 nodes vs 5-10 assets. The conjunction improvement is thanks to Lagrange relays. All metrics are backed by our simulation engine. (1 minute)</a:t>
+              <a:t>Be honest. Left column is simulated: 241-node topology, RL routing converges in 140 episodes, autonomous conjunction reroute, BB84 detection, 200x radiation reduction. Right column is design targets: 2-200 Mbps from link model, &gt;95% availability and cost are goals not yet measured. (1 minute)</a:t>
             </a:r>
           </a:p>
         </p:txBody>
@@ -3351,7 +3351,7 @@
           <a:lstStyle/>
           <a:p>
             <a:r>
-              <a:t>Summarize the four key numbers: 10-100x faster, &gt;95% availability, AI-powered routing, quantum-secure. Invite questions confidently. Make eye contact. Point to the live demo link. Thank the audience. (30 seconds)</a:t>
+              <a:t>Summarize: simulated achievements are 241-node topology, RL routing, QKD security, 200x radiation reduction. Design targets are 10-100x data rate and &gt;95% availability. Invite questions confidently. Thank the audience. (30 seconds)</a:t>
             </a:r>
           </a:p>
         </p:txBody>
@@ -13341,7 +13341,7 @@
               </a:defRPr>
             </a:pPr>
             <a:r>
-              <a:t>10–100x Faster Than RF</a:t>
+              <a:t>10–100x Capability Over RF</a:t>
             </a:r>
           </a:p>
         </p:txBody>
@@ -26633,7 +26633,7 @@
               </a:defRPr>
             </a:pPr>
             <a:r>
-              <a:t>Link utilization (no wasted bandwidth)</a:t>
+              <a:t>Link utilization (target)</a:t>
             </a:r>
           </a:p>
         </p:txBody>
@@ -32592,7 +32592,7 @@
                         </a:defRPr>
                       </a:pPr>
                       <a:r>
-                        <a:t>10-100×</a:t>
+                        <a:t>10-100× capability</a:t>
                       </a:r>
                     </a:p>
                   </a:txBody>
@@ -32690,7 +32690,7 @@
                         </a:defRPr>
                       </a:pPr>
                       <a:r>
-                        <a:t>10-20×</a:t>
+                        <a:t>10-20× (target)</a:t>
                       </a:r>
                     </a:p>
                   </a:txBody>
@@ -33156,7 +33156,7 @@
                         </a:defRPr>
                       </a:pPr>
                       <a:r>
-                        <a:t>50-70% via L4/L5</a:t>
+                        <a:t>L4/L5 relay (target)</a:t>
                       </a:r>
                     </a:p>
                   </a:txBody>
@@ -33180,7 +33180,7 @@
                         </a:defRPr>
                       </a:pPr>
                       <a:r>
-                        <a:t>+50-70%</a:t>
+                        <a:t>+50-70% (target)</a:t>
                       </a:r>
                     </a:p>
                   </a:txBody>
@@ -33503,7 +33503,7 @@
               </a:defRPr>
             </a:pPr>
             <a:r>
-              <a:t>AETHERIX achieves 10-100x improvement across all key metrics</a:t>
+              <a:t>Model-based targets vs current MRO baseline</a:t>
             </a:r>
           </a:p>
         </p:txBody>
@@ -34079,7 +34079,7 @@
               </a:defRPr>
             </a:pPr>
             <a:r>
-              <a:t>27</a:t>
+              <a:t>25</a:t>
             </a:r>
           </a:p>
           <a:p>
@@ -36593,7 +36593,7 @@
           </a:solidFill>
           <a:ln w="12700">
             <a:solidFill>
-              <a:srgbClr val="2ECC71"/>
+              <a:srgbClr val="009EFF"/>
             </a:solidFill>
           </a:ln>
           <a:effectLst/>
@@ -36619,7 +36619,7 @@
             <a:pPr algn="ctr">
               <a:defRPr sz="2400" b="1">
                 <a:solidFill>
-                  <a:srgbClr val="2ECC71"/>
+                  <a:srgbClr val="009EFF"/>
                 </a:solidFill>
                 <a:latin typeface="Calibri"/>
               </a:defRPr>
@@ -36644,7 +36644,7 @@
               </a:defRPr>
             </a:pPr>
             <a:r>
-              <a:t>Data Rate</a:t>
+              <a:t>Target Speedup ♦</a:t>
             </a:r>
           </a:p>
         </p:txBody>
@@ -36668,7 +36668,7 @@
           </a:solidFill>
           <a:ln w="12700">
             <a:solidFill>
-              <a:srgbClr val="009EFF"/>
+              <a:srgbClr val="2ECC71"/>
             </a:solidFill>
           </a:ln>
           <a:effectLst/>
@@ -36694,7 +36694,7 @@
             <a:pPr algn="ctr">
               <a:defRPr sz="2400" b="1">
                 <a:solidFill>
-                  <a:srgbClr val="009EFF"/>
+                  <a:srgbClr val="2ECC71"/>
                 </a:solidFill>
                 <a:latin typeface="Calibri"/>
               </a:defRPr>
@@ -36719,7 +36719,7 @@
               </a:defRPr>
             </a:pPr>
             <a:r>
-              <a:t>Availability (tgt)</a:t>
+              <a:t>Availability (target)</a:t>
             </a:r>
           </a:p>
         </p:txBody>
@@ -36794,7 +36794,7 @@
               </a:defRPr>
             </a:pPr>
             <a:r>
-              <a:t>Adaptive Routing</a:t>
+              <a:t>Adaptive Routing ✓</a:t>
             </a:r>
           </a:p>
         </p:txBody>
@@ -36869,7 +36869,7 @@
               </a:defRPr>
             </a:pPr>
             <a:r>
-              <a:t>Quantum Security</a:t>
+              <a:t>Quantum Security ✓</a:t>
             </a:r>
           </a:p>
         </p:txBody>
@@ -37188,7 +37188,7 @@
           </a:solidFill>
           <a:ln w="12700">
             <a:solidFill>
-              <a:srgbClr val="2ECC71"/>
+              <a:srgbClr val="009EFF"/>
             </a:solidFill>
           </a:ln>
           <a:effectLst/>
@@ -37214,7 +37214,7 @@
             <a:pPr algn="ctr">
               <a:defRPr sz="2400" b="1">
                 <a:solidFill>
-                  <a:srgbClr val="2ECC71"/>
+                  <a:srgbClr val="009EFF"/>
                 </a:solidFill>
                 <a:latin typeface="Calibri"/>
               </a:defRPr>
@@ -37239,7 +37239,7 @@
               </a:defRPr>
             </a:pPr>
             <a:r>
-              <a:t>Data Rate</a:t>
+              <a:t>Target Speedup ♦</a:t>
             </a:r>
           </a:p>
         </p:txBody>
@@ -37263,7 +37263,7 @@
           </a:solidFill>
           <a:ln w="12700">
             <a:solidFill>
-              <a:srgbClr val="009EFF"/>
+              <a:srgbClr val="2ECC71"/>
             </a:solidFill>
           </a:ln>
           <a:effectLst/>
@@ -37289,7 +37289,7 @@
             <a:pPr algn="ctr">
               <a:defRPr sz="2400" b="1">
                 <a:solidFill>
-                  <a:srgbClr val="009EFF"/>
+                  <a:srgbClr val="2ECC71"/>
                 </a:solidFill>
                 <a:latin typeface="Calibri"/>
               </a:defRPr>
@@ -37314,7 +37314,7 @@
               </a:defRPr>
             </a:pPr>
             <a:r>
-              <a:t>Availability (tgt)</a:t>
+              <a:t>Availability (target)</a:t>
             </a:r>
           </a:p>
         </p:txBody>
@@ -37389,7 +37389,7 @@
               </a:defRPr>
             </a:pPr>
             <a:r>
-              <a:t>Adaptive Routing</a:t>
+              <a:t>Adaptive Routing ✓</a:t>
             </a:r>
           </a:p>
         </p:txBody>
@@ -37464,7 +37464,7 @@
               </a:defRPr>
             </a:pPr>
             <a:r>
-              <a:t>Quantum Security</a:t>
+              <a:t>Quantum Security ✓</a:t>
             </a:r>
           </a:p>
         </p:txBody>

</xml_diff>